<commit_message>
Add HCRL dataset introduction slide
</commit_message>
<xml_diff>
--- a/UGV_FHE_Presentation_Final.pptx
+++ b/UGV_FHE_Presentation_Final.pptx
@@ -13,6 +13,7 @@
     <p:sldId id="261" r:id="rId12"/>
     <p:sldId id="262" r:id="rId13"/>
     <p:sldId id="263" r:id="rId14"/>
+    <p:sldId id="264" r:id="rId15"/>
   </p:sldIdLst>
   <p:sldSz cx="9144000" cy="6858000" type="screen4x3"/>
   <p:notesSz cx="6858000" cy="9144000"/>
@@ -3222,12 +3223,17 @@
           </a:p>
           <a:p>
             <a:r>
-              <a:t>5. 모델 검증 (오픈 데이터셋 활용)</a:t>
-            </a:r>
-          </a:p>
-          <a:p>
-            <a:r>
-              <a:t>6. 결론 및 향후 과제</a:t>
+              <a:t>5. 검증 데이터셋 소개 (고려대 HCRL)</a:t>
+            </a:r>
+          </a:p>
+          <a:p>
+            <a:r>
+              <a:t>6. 최종 모델 검증 결과</a:t>
+            </a:r>
+          </a:p>
+          <a:p>
+            <a:r>
+              <a:t>7. 결론 및 향후 과제</a:t>
             </a:r>
           </a:p>
         </p:txBody>
@@ -3619,7 +3625,7 @@
           <a:lstStyle/>
           <a:p>
             <a:r>
-              <a:t>5. 모델 검증 (오픈 데이터셋 활용)</a:t>
+              <a:t>5. 검증 데이터셋 소개 (고려대 HCRL)</a:t>
             </a:r>
           </a:p>
         </p:txBody>
@@ -3640,31 +3646,49 @@
           <a:lstStyle/>
           <a:p>
             <a:r>
-              <a:t>국제적으로 검증된 공인 데이터셋 도입</a:t>
+              <a:t>고려대학교 HCRL(Hacking and Countermeasure Research Lab)</a:t>
             </a:r>
           </a:p>
           <a:p>
             <a:pPr lvl="1"/>
             <a:r>
-              <a:t>'Car Hacking Dataset' 등 실제 차량(CAN Bus) 해킹 데이터를 활용하여 모델 검증</a:t>
+              <a:t>자율주행 및 자동차 보안 분야에서 국제적으로 가장 널리 인용되는 공인 데이터셋</a:t>
             </a:r>
           </a:p>
           <a:p>
             <a:pPr/>
             <a:r>
-              <a:t>검증 방법 및 결과</a:t>
+              <a:t>데이터 수집 환경</a:t>
             </a:r>
           </a:p>
           <a:p>
             <a:pPr lvl="1"/>
             <a:r>
-              <a:t>정상 주행 패턴과 악의적인 조작(속도 급증, 조향각 변조, DoS 공격) 데이터 분류</a:t>
+              <a:t>실제 차량(기아 쏘울)의 내부 통신망(CAN Bus)에서 실주행 중 트래픽 추출</a:t>
+            </a:r>
+          </a:p>
+          <a:p>
+            <a:pPr/>
+            <a:r>
+              <a:t>4대 치명적 해킹 시나리오 포함</a:t>
             </a:r>
           </a:p>
           <a:p>
             <a:pPr lvl="1"/>
             <a:r>
-              <a:t>동형암호화된 상태에서도 평문과 동일한 수준의 높은 탐지 정확도 유지 입증</a:t>
+              <a:t>DoS 공격: 통신망 전체 마비 시도</a:t>
+            </a:r>
+          </a:p>
+          <a:p>
+            <a:pPr lvl="1"/>
+            <a:r>
+              <a:t>Fuzzy 공격: 무작위 교란 신호 주입</a:t>
+            </a:r>
+          </a:p>
+          <a:p>
+            <a:pPr lvl="1"/>
+            <a:r>
+              <a:t>RPM/Gear Spoofing 공격: 차량 속도 및 기어 강제 조작 (본 연구의 핵심 시나리오)</a:t>
             </a:r>
           </a:p>
         </p:txBody>
@@ -3703,7 +3727,7 @@
           <a:lstStyle/>
           <a:p>
             <a:r>
-              <a:t>6. 결론 및 향후 과제</a:t>
+              <a:t>6. 최종 모델 검증 결과</a:t>
             </a:r>
           </a:p>
         </p:txBody>
@@ -3724,19 +3748,109 @@
           <a:lstStyle/>
           <a:p>
             <a:r>
+              <a:t>HCRL 데이터셋 대상 로지스틱 회귀 모델의 FHE 검증</a:t>
+            </a:r>
+          </a:p>
+          <a:p>
+            <a:pPr lvl="1"/>
+            <a:r>
+              <a:t>탐지 정확도 (Accuracy)</a:t>
+            </a:r>
+          </a:p>
+          <a:p>
+            <a:pPr lvl="2"/>
+            <a:r>
+              <a:t>평문 상태(79.5%)와 동형암호 상태(79.0%)에서 동일한 수준의 높은 방어율 입증</a:t>
+            </a:r>
+          </a:p>
+          <a:p>
+            <a:pPr lvl="1"/>
+            <a:r>
+              <a:t>초저지연 실시간성 (Ultra-Low Latency)</a:t>
+            </a:r>
+          </a:p>
+          <a:p>
+            <a:pPr lvl="2"/>
+            <a:r>
+              <a:t>암호문 추론 지연시간 평균 2.47ms 달성 (목표치 34.4ms를 월등히 상회)</a:t>
+            </a:r>
+          </a:p>
+          <a:p>
+            <a:pPr lvl="1"/>
+            <a:r>
+              <a:t>결론: 고속 주행 차량에서도 딜레이 없는 완벽한 실시간 해킹 방어 가능</a:t>
+            </a:r>
+          </a:p>
+        </p:txBody>
+      </p:sp>
+    </p:spTree>
+  </p:cSld>
+  <p:clrMapOvr>
+    <a:masterClrMapping/>
+  </p:clrMapOvr>
+</p:sld>
+</file>
+
+<file path=ppt/slides/slide9.xml><?xml version="1.0" encoding="utf-8"?>
+<p:sld xmlns:a="http://schemas.openxmlformats.org/drawingml/2006/main" xmlns:p="http://schemas.openxmlformats.org/presentationml/2006/main" xmlns:r="http://schemas.openxmlformats.org/officeDocument/2006/relationships">
+  <p:cSld>
+    <p:spTree>
+      <p:nvGrpSpPr>
+        <p:cNvPr id="1" name=""/>
+        <p:cNvGrpSpPr/>
+        <p:nvPr/>
+      </p:nvGrpSpPr>
+      <p:grpSpPr/>
+      <p:sp>
+        <p:nvSpPr>
+          <p:cNvPr id="2" name="Title 1"/>
+          <p:cNvSpPr>
+            <a:spLocks noGrp="1"/>
+          </p:cNvSpPr>
+          <p:nvPr>
+            <p:ph type="title"/>
+          </p:nvPr>
+        </p:nvSpPr>
+        <p:spPr/>
+        <p:txBody>
+          <a:bodyPr/>
+          <a:lstStyle/>
+          <a:p>
+            <a:r>
+              <a:t>7. 결론 및 향후 과제</a:t>
+            </a:r>
+          </a:p>
+        </p:txBody>
+      </p:sp>
+      <p:sp>
+        <p:nvSpPr>
+          <p:cNvPr id="3" name="Content Placeholder 2"/>
+          <p:cNvSpPr>
+            <a:spLocks noGrp="1"/>
+          </p:cNvSpPr>
+          <p:nvPr>
+            <p:ph idx="1"/>
+          </p:nvPr>
+        </p:nvSpPr>
+        <p:spPr/>
+        <p:txBody>
+          <a:bodyPr/>
+          <a:lstStyle/>
+          <a:p>
+            <a:r>
               <a:t>결론</a:t>
             </a:r>
           </a:p>
           <a:p>
             <a:pPr lvl="1"/>
             <a:r>
-              <a:t>동형암호를 통한 데이터 보호와 로지스틱 회귀를 통한 초저지연(34.4ms) 방어 시스템의 융합 성공</a:t>
+              <a:t>동형암호를 통한 데이터 보호와 로지스틱 회귀를 통한 초저지연(2.47ms) 방어 시스템의 융합 성공</a:t>
             </a:r>
           </a:p>
           <a:p>
             <a:pPr lvl="1"/>
             <a:r>
-              <a:t>공인 오픈 데이터셋을 통해 실전 모델로서의 타당성 및 정확도 입증</a:t>
+              <a:t>HCRL 공인 데이터셋을 통해 실전 모델로서의 타당성 및 정확도 입증</a:t>
             </a:r>
           </a:p>
           <a:p>

</xml_diff>

<commit_message>
Add HCRL diagram to PPT
</commit_message>
<xml_diff>
--- a/UGV_FHE_Presentation_Final.pptx
+++ b/UGV_FHE_Presentation_Final.pptx
@@ -3693,6 +3693,30 @@
           </a:p>
         </p:txBody>
       </p:sp>
+      <p:pic>
+        <p:nvPicPr>
+          <p:cNvPr id="4" name="Picture 3" descr="hcrl_dataset_architecture.png"/>
+          <p:cNvPicPr>
+            <a:picLocks noChangeAspect="1"/>
+          </p:cNvPicPr>
+          <p:nvPr/>
+        </p:nvPicPr>
+        <p:blipFill>
+          <a:blip r:embed="rId2"/>
+          <a:stretch>
+            <a:fillRect/>
+          </a:stretch>
+        </p:blipFill>
+        <p:spPr>
+          <a:xfrm>
+            <a:off x="4114800" y="1828800"/>
+            <a:ext cx="4572000" cy="2743200"/>
+          </a:xfrm>
+          <a:prstGeom prst="rect">
+            <a:avLst/>
+          </a:prstGeom>
+        </p:spPr>
+      </p:pic>
     </p:spTree>
   </p:cSld>
   <p:clrMapOvr>

</xml_diff>